<commit_message>
Extra fallback (for demo purposes) to public wifi of employer, adjusted spacing in presentation slightly.
</commit_message>
<xml_diff>
--- a/claude/presentation.pptx
+++ b/claude/presentation.pptx
@@ -5,23 +5,23 @@
     <p:sldMasterId id="2147483648" r:id="rId1"/>
   </p:sldMasterIdLst>
   <p:sldIdLst>
-    <p:sldId id="256" r:id="rId7"/>
-    <p:sldId id="257" r:id="rId8"/>
-    <p:sldId id="258" r:id="rId9"/>
-    <p:sldId id="259" r:id="rId10"/>
-    <p:sldId id="260" r:id="rId11"/>
-    <p:sldId id="261" r:id="rId12"/>
-    <p:sldId id="262" r:id="rId13"/>
-    <p:sldId id="263" r:id="rId14"/>
-    <p:sldId id="264" r:id="rId15"/>
-    <p:sldId id="265" r:id="rId16"/>
-    <p:sldId id="266" r:id="rId17"/>
-    <p:sldId id="267" r:id="rId18"/>
-    <p:sldId id="268" r:id="rId19"/>
-    <p:sldId id="269" r:id="rId20"/>
-    <p:sldId id="270" r:id="rId21"/>
+    <p:sldId id="256" r:id="rId2"/>
+    <p:sldId id="257" r:id="rId3"/>
+    <p:sldId id="258" r:id="rId4"/>
+    <p:sldId id="259" r:id="rId5"/>
+    <p:sldId id="260" r:id="rId6"/>
+    <p:sldId id="261" r:id="rId7"/>
+    <p:sldId id="262" r:id="rId8"/>
+    <p:sldId id="263" r:id="rId9"/>
+    <p:sldId id="264" r:id="rId10"/>
+    <p:sldId id="265" r:id="rId11"/>
+    <p:sldId id="266" r:id="rId12"/>
+    <p:sldId id="267" r:id="rId13"/>
+    <p:sldId id="268" r:id="rId14"/>
+    <p:sldId id="269" r:id="rId15"/>
+    <p:sldId id="270" r:id="rId16"/>
   </p:sldIdLst>
-  <p:sldSz cx="12188952" cy="6858000" type="screen4x3"/>
+  <p:sldSz cx="12188825" cy="6858000"/>
   <p:notesSz cx="6858000" cy="9144000"/>
   <p:defaultTextStyle>
     <a:defPPr>
@@ -118,6 +118,22 @@
       </a:defRPr>
     </a:lvl9pPr>
   </p:defaultTextStyle>
+  <p:extLst>
+    <p:ext uri="{EFAFB233-063F-42B5-8137-9DF3F51BA10A}">
+      <p15:sldGuideLst xmlns:p15="http://schemas.microsoft.com/office/powerpoint/2012/main">
+        <p15:guide id="1" orient="horz" pos="2160">
+          <p15:clr>
+            <a:srgbClr val="A4A3A4"/>
+          </p15:clr>
+        </p15:guide>
+        <p15:guide id="2" pos="2880">
+          <p15:clr>
+            <a:srgbClr val="A4A3A4"/>
+          </p15:clr>
+        </p15:guide>
+      </p15:sldGuideLst>
+    </p:ext>
+  </p:extLst>
 </p:presentation>
 </file>
 
@@ -159,10 +175,9 @@
           <a:lstStyle/>
           <a:p>
             <a:r>
-              <a:rPr lang="en-US" smtClean="0"/>
+              <a:rPr lang="en-US"/>
               <a:t>Click to edit Master title style</a:t>
             </a:r>
-            <a:endParaRPr lang="en-US"/>
           </a:p>
         </p:txBody>
       </p:sp>
@@ -278,10 +293,9 @@
           </a:lstStyle>
           <a:p>
             <a:r>
-              <a:rPr lang="en-US" smtClean="0"/>
+              <a:rPr lang="en-US"/>
               <a:t>Click to edit Master subtitle style</a:t>
             </a:r>
-            <a:endParaRPr lang="en-US"/>
           </a:p>
         </p:txBody>
       </p:sp>
@@ -302,7 +316,7 @@
           <a:p>
             <a:fld id="{5BCAD085-E8A6-8845-BD4E-CB4CCA059FC4}" type="datetimeFigureOut">
               <a:rPr lang="en-US" smtClean="0"/>
-              <a:t>1/27/13</a:t>
+              <a:t>3/24/2026</a:t>
             </a:fld>
             <a:endParaRPr lang="en-US"/>
           </a:p>
@@ -344,7 +358,7 @@
           <a:p>
             <a:fld id="{C1FF6DA9-008F-8B48-92A6-B652298478BF}" type="slidenum">
               <a:rPr lang="en-US" smtClean="0"/>
-              <a:t>‹#›</a:t>
+              <a:t>‹nr.›</a:t>
             </a:fld>
             <a:endParaRPr lang="en-US"/>
           </a:p>
@@ -396,10 +410,9 @@
           <a:lstStyle/>
           <a:p>
             <a:r>
-              <a:rPr lang="en-US" smtClean="0"/>
+              <a:rPr lang="en-US"/>
               <a:t>Click to edit Master title style</a:t>
             </a:r>
-            <a:endParaRPr lang="en-US"/>
           </a:p>
         </p:txBody>
       </p:sp>
@@ -420,38 +433,37 @@
           <a:p>
             <a:pPr lvl="0"/>
             <a:r>
-              <a:rPr lang="en-US" smtClean="0"/>
+              <a:rPr lang="en-US"/>
               <a:t>Click to edit Master text styles</a:t>
             </a:r>
           </a:p>
           <a:p>
             <a:pPr lvl="1"/>
             <a:r>
-              <a:rPr lang="en-US" smtClean="0"/>
+              <a:rPr lang="en-US"/>
               <a:t>Second level</a:t>
             </a:r>
           </a:p>
           <a:p>
             <a:pPr lvl="2"/>
             <a:r>
-              <a:rPr lang="en-US" smtClean="0"/>
+              <a:rPr lang="en-US"/>
               <a:t>Third level</a:t>
             </a:r>
           </a:p>
           <a:p>
             <a:pPr lvl="3"/>
             <a:r>
-              <a:rPr lang="en-US" smtClean="0"/>
+              <a:rPr lang="en-US"/>
               <a:t>Fourth level</a:t>
             </a:r>
           </a:p>
           <a:p>
             <a:pPr lvl="4"/>
             <a:r>
-              <a:rPr lang="en-US" smtClean="0"/>
+              <a:rPr lang="en-US"/>
               <a:t>Fifth level</a:t>
             </a:r>
-            <a:endParaRPr lang="en-US"/>
           </a:p>
         </p:txBody>
       </p:sp>
@@ -472,7 +484,7 @@
           <a:p>
             <a:fld id="{5BCAD085-E8A6-8845-BD4E-CB4CCA059FC4}" type="datetimeFigureOut">
               <a:rPr lang="en-US" smtClean="0"/>
-              <a:t>1/27/13</a:t>
+              <a:t>3/24/2026</a:t>
             </a:fld>
             <a:endParaRPr lang="en-US"/>
           </a:p>
@@ -514,7 +526,7 @@
           <a:p>
             <a:fld id="{C1FF6DA9-008F-8B48-92A6-B652298478BF}" type="slidenum">
               <a:rPr lang="en-US" smtClean="0"/>
-              <a:t>‹#›</a:t>
+              <a:t>‹nr.›</a:t>
             </a:fld>
             <a:endParaRPr lang="en-US"/>
           </a:p>
@@ -571,10 +583,9 @@
           <a:lstStyle/>
           <a:p>
             <a:r>
-              <a:rPr lang="en-US" smtClean="0"/>
+              <a:rPr lang="en-US"/>
               <a:t>Click to edit Master title style</a:t>
             </a:r>
-            <a:endParaRPr lang="en-US"/>
           </a:p>
         </p:txBody>
       </p:sp>
@@ -600,38 +611,37 @@
           <a:p>
             <a:pPr lvl="0"/>
             <a:r>
-              <a:rPr lang="en-US" smtClean="0"/>
+              <a:rPr lang="en-US"/>
               <a:t>Click to edit Master text styles</a:t>
             </a:r>
           </a:p>
           <a:p>
             <a:pPr lvl="1"/>
             <a:r>
-              <a:rPr lang="en-US" smtClean="0"/>
+              <a:rPr lang="en-US"/>
               <a:t>Second level</a:t>
             </a:r>
           </a:p>
           <a:p>
             <a:pPr lvl="2"/>
             <a:r>
-              <a:rPr lang="en-US" smtClean="0"/>
+              <a:rPr lang="en-US"/>
               <a:t>Third level</a:t>
             </a:r>
           </a:p>
           <a:p>
             <a:pPr lvl="3"/>
             <a:r>
-              <a:rPr lang="en-US" smtClean="0"/>
+              <a:rPr lang="en-US"/>
               <a:t>Fourth level</a:t>
             </a:r>
           </a:p>
           <a:p>
             <a:pPr lvl="4"/>
             <a:r>
-              <a:rPr lang="en-US" smtClean="0"/>
+              <a:rPr lang="en-US"/>
               <a:t>Fifth level</a:t>
             </a:r>
-            <a:endParaRPr lang="en-US"/>
           </a:p>
         </p:txBody>
       </p:sp>
@@ -652,7 +662,7 @@
           <a:p>
             <a:fld id="{5BCAD085-E8A6-8845-BD4E-CB4CCA059FC4}" type="datetimeFigureOut">
               <a:rPr lang="en-US" smtClean="0"/>
-              <a:t>1/27/13</a:t>
+              <a:t>3/24/2026</a:t>
             </a:fld>
             <a:endParaRPr lang="en-US"/>
           </a:p>
@@ -694,7 +704,7 @@
           <a:p>
             <a:fld id="{C1FF6DA9-008F-8B48-92A6-B652298478BF}" type="slidenum">
               <a:rPr lang="en-US" smtClean="0"/>
-              <a:t>‹#›</a:t>
+              <a:t>‹nr.›</a:t>
             </a:fld>
             <a:endParaRPr lang="en-US"/>
           </a:p>
@@ -746,10 +756,9 @@
           <a:lstStyle/>
           <a:p>
             <a:r>
-              <a:rPr lang="en-US" smtClean="0"/>
+              <a:rPr lang="en-US"/>
               <a:t>Click to edit Master title style</a:t>
             </a:r>
-            <a:endParaRPr lang="en-US"/>
           </a:p>
         </p:txBody>
       </p:sp>
@@ -770,38 +779,37 @@
           <a:p>
             <a:pPr lvl="0"/>
             <a:r>
-              <a:rPr lang="en-US" smtClean="0"/>
+              <a:rPr lang="en-US"/>
               <a:t>Click to edit Master text styles</a:t>
             </a:r>
           </a:p>
           <a:p>
             <a:pPr lvl="1"/>
             <a:r>
-              <a:rPr lang="en-US" smtClean="0"/>
+              <a:rPr lang="en-US"/>
               <a:t>Second level</a:t>
             </a:r>
           </a:p>
           <a:p>
             <a:pPr lvl="2"/>
             <a:r>
-              <a:rPr lang="en-US" smtClean="0"/>
+              <a:rPr lang="en-US"/>
               <a:t>Third level</a:t>
             </a:r>
           </a:p>
           <a:p>
             <a:pPr lvl="3"/>
             <a:r>
-              <a:rPr lang="en-US" smtClean="0"/>
+              <a:rPr lang="en-US"/>
               <a:t>Fourth level</a:t>
             </a:r>
           </a:p>
           <a:p>
             <a:pPr lvl="4"/>
             <a:r>
-              <a:rPr lang="en-US" smtClean="0"/>
+              <a:rPr lang="en-US"/>
               <a:t>Fifth level</a:t>
             </a:r>
-            <a:endParaRPr lang="en-US"/>
           </a:p>
         </p:txBody>
       </p:sp>
@@ -822,7 +830,7 @@
           <a:p>
             <a:fld id="{5BCAD085-E8A6-8845-BD4E-CB4CCA059FC4}" type="datetimeFigureOut">
               <a:rPr lang="en-US" smtClean="0"/>
-              <a:t>1/27/13</a:t>
+              <a:t>3/24/2026</a:t>
             </a:fld>
             <a:endParaRPr lang="en-US"/>
           </a:p>
@@ -864,7 +872,7 @@
           <a:p>
             <a:fld id="{C1FF6DA9-008F-8B48-92A6-B652298478BF}" type="slidenum">
               <a:rPr lang="en-US" smtClean="0"/>
-              <a:t>‹#›</a:t>
+              <a:t>‹nr.›</a:t>
             </a:fld>
             <a:endParaRPr lang="en-US"/>
           </a:p>
@@ -925,10 +933,9 @@
           </a:lstStyle>
           <a:p>
             <a:r>
-              <a:rPr lang="en-US" smtClean="0"/>
+              <a:rPr lang="en-US"/>
               <a:t>Click to edit Master title style</a:t>
             </a:r>
-            <a:endParaRPr lang="en-US"/>
           </a:p>
         </p:txBody>
       </p:sp>
@@ -1045,7 +1052,7 @@
           <a:p>
             <a:pPr lvl="0"/>
             <a:r>
-              <a:rPr lang="en-US" smtClean="0"/>
+              <a:rPr lang="en-US"/>
               <a:t>Click to edit Master text styles</a:t>
             </a:r>
           </a:p>
@@ -1068,7 +1075,7 @@
           <a:p>
             <a:fld id="{5BCAD085-E8A6-8845-BD4E-CB4CCA059FC4}" type="datetimeFigureOut">
               <a:rPr lang="en-US" smtClean="0"/>
-              <a:t>1/27/13</a:t>
+              <a:t>3/24/2026</a:t>
             </a:fld>
             <a:endParaRPr lang="en-US"/>
           </a:p>
@@ -1110,7 +1117,7 @@
           <a:p>
             <a:fld id="{C1FF6DA9-008F-8B48-92A6-B652298478BF}" type="slidenum">
               <a:rPr lang="en-US" smtClean="0"/>
-              <a:t>‹#›</a:t>
+              <a:t>‹nr.›</a:t>
             </a:fld>
             <a:endParaRPr lang="en-US"/>
           </a:p>
@@ -1162,10 +1169,9 @@
           <a:lstStyle/>
           <a:p>
             <a:r>
-              <a:rPr lang="en-US" smtClean="0"/>
+              <a:rPr lang="en-US"/>
               <a:t>Click to edit Master title style</a:t>
             </a:r>
-            <a:endParaRPr lang="en-US"/>
           </a:p>
         </p:txBody>
       </p:sp>
@@ -1219,38 +1225,37 @@
           <a:p>
             <a:pPr lvl="0"/>
             <a:r>
-              <a:rPr lang="en-US" smtClean="0"/>
+              <a:rPr lang="en-US"/>
               <a:t>Click to edit Master text styles</a:t>
             </a:r>
           </a:p>
           <a:p>
             <a:pPr lvl="1"/>
             <a:r>
-              <a:rPr lang="en-US" smtClean="0"/>
+              <a:rPr lang="en-US"/>
               <a:t>Second level</a:t>
             </a:r>
           </a:p>
           <a:p>
             <a:pPr lvl="2"/>
             <a:r>
-              <a:rPr lang="en-US" smtClean="0"/>
+              <a:rPr lang="en-US"/>
               <a:t>Third level</a:t>
             </a:r>
           </a:p>
           <a:p>
             <a:pPr lvl="3"/>
             <a:r>
-              <a:rPr lang="en-US" smtClean="0"/>
+              <a:rPr lang="en-US"/>
               <a:t>Fourth level</a:t>
             </a:r>
           </a:p>
           <a:p>
             <a:pPr lvl="4"/>
             <a:r>
-              <a:rPr lang="en-US" smtClean="0"/>
+              <a:rPr lang="en-US"/>
               <a:t>Fifth level</a:t>
             </a:r>
-            <a:endParaRPr lang="en-US"/>
           </a:p>
         </p:txBody>
       </p:sp>
@@ -1304,38 +1309,37 @@
           <a:p>
             <a:pPr lvl="0"/>
             <a:r>
-              <a:rPr lang="en-US" smtClean="0"/>
+              <a:rPr lang="en-US"/>
               <a:t>Click to edit Master text styles</a:t>
             </a:r>
           </a:p>
           <a:p>
             <a:pPr lvl="1"/>
             <a:r>
-              <a:rPr lang="en-US" smtClean="0"/>
+              <a:rPr lang="en-US"/>
               <a:t>Second level</a:t>
             </a:r>
           </a:p>
           <a:p>
             <a:pPr lvl="2"/>
             <a:r>
-              <a:rPr lang="en-US" smtClean="0"/>
+              <a:rPr lang="en-US"/>
               <a:t>Third level</a:t>
             </a:r>
           </a:p>
           <a:p>
             <a:pPr lvl="3"/>
             <a:r>
-              <a:rPr lang="en-US" smtClean="0"/>
+              <a:rPr lang="en-US"/>
               <a:t>Fourth level</a:t>
             </a:r>
           </a:p>
           <a:p>
             <a:pPr lvl="4"/>
             <a:r>
-              <a:rPr lang="en-US" smtClean="0"/>
+              <a:rPr lang="en-US"/>
               <a:t>Fifth level</a:t>
             </a:r>
-            <a:endParaRPr lang="en-US"/>
           </a:p>
         </p:txBody>
       </p:sp>
@@ -1356,7 +1360,7 @@
           <a:p>
             <a:fld id="{5BCAD085-E8A6-8845-BD4E-CB4CCA059FC4}" type="datetimeFigureOut">
               <a:rPr lang="en-US" smtClean="0"/>
-              <a:t>1/27/13</a:t>
+              <a:t>3/24/2026</a:t>
             </a:fld>
             <a:endParaRPr lang="en-US"/>
           </a:p>
@@ -1398,7 +1402,7 @@
           <a:p>
             <a:fld id="{C1FF6DA9-008F-8B48-92A6-B652298478BF}" type="slidenum">
               <a:rPr lang="en-US" smtClean="0"/>
-              <a:t>‹#›</a:t>
+              <a:t>‹nr.›</a:t>
             </a:fld>
             <a:endParaRPr lang="en-US"/>
           </a:p>
@@ -1454,10 +1458,9 @@
           </a:lstStyle>
           <a:p>
             <a:r>
-              <a:rPr lang="en-US" smtClean="0"/>
+              <a:rPr lang="en-US"/>
               <a:t>Click to edit Master title style</a:t>
             </a:r>
-            <a:endParaRPr lang="en-US"/>
           </a:p>
         </p:txBody>
       </p:sp>
@@ -1520,7 +1523,7 @@
           <a:p>
             <a:pPr lvl="0"/>
             <a:r>
-              <a:rPr lang="en-US" smtClean="0"/>
+              <a:rPr lang="en-US"/>
               <a:t>Click to edit Master text styles</a:t>
             </a:r>
           </a:p>
@@ -1576,38 +1579,37 @@
           <a:p>
             <a:pPr lvl="0"/>
             <a:r>
-              <a:rPr lang="en-US" smtClean="0"/>
+              <a:rPr lang="en-US"/>
               <a:t>Click to edit Master text styles</a:t>
             </a:r>
           </a:p>
           <a:p>
             <a:pPr lvl="1"/>
             <a:r>
-              <a:rPr lang="en-US" smtClean="0"/>
+              <a:rPr lang="en-US"/>
               <a:t>Second level</a:t>
             </a:r>
           </a:p>
           <a:p>
             <a:pPr lvl="2"/>
             <a:r>
-              <a:rPr lang="en-US" smtClean="0"/>
+              <a:rPr lang="en-US"/>
               <a:t>Third level</a:t>
             </a:r>
           </a:p>
           <a:p>
             <a:pPr lvl="3"/>
             <a:r>
-              <a:rPr lang="en-US" smtClean="0"/>
+              <a:rPr lang="en-US"/>
               <a:t>Fourth level</a:t>
             </a:r>
           </a:p>
           <a:p>
             <a:pPr lvl="4"/>
             <a:r>
-              <a:rPr lang="en-US" smtClean="0"/>
+              <a:rPr lang="en-US"/>
               <a:t>Fifth level</a:t>
             </a:r>
-            <a:endParaRPr lang="en-US"/>
           </a:p>
         </p:txBody>
       </p:sp>
@@ -1670,7 +1672,7 @@
           <a:p>
             <a:pPr lvl="0"/>
             <a:r>
-              <a:rPr lang="en-US" smtClean="0"/>
+              <a:rPr lang="en-US"/>
               <a:t>Click to edit Master text styles</a:t>
             </a:r>
           </a:p>
@@ -1726,38 +1728,37 @@
           <a:p>
             <a:pPr lvl="0"/>
             <a:r>
-              <a:rPr lang="en-US" smtClean="0"/>
+              <a:rPr lang="en-US"/>
               <a:t>Click to edit Master text styles</a:t>
             </a:r>
           </a:p>
           <a:p>
             <a:pPr lvl="1"/>
             <a:r>
-              <a:rPr lang="en-US" smtClean="0"/>
+              <a:rPr lang="en-US"/>
               <a:t>Second level</a:t>
             </a:r>
           </a:p>
           <a:p>
             <a:pPr lvl="2"/>
             <a:r>
-              <a:rPr lang="en-US" smtClean="0"/>
+              <a:rPr lang="en-US"/>
               <a:t>Third level</a:t>
             </a:r>
           </a:p>
           <a:p>
             <a:pPr lvl="3"/>
             <a:r>
-              <a:rPr lang="en-US" smtClean="0"/>
+              <a:rPr lang="en-US"/>
               <a:t>Fourth level</a:t>
             </a:r>
           </a:p>
           <a:p>
             <a:pPr lvl="4"/>
             <a:r>
-              <a:rPr lang="en-US" smtClean="0"/>
+              <a:rPr lang="en-US"/>
               <a:t>Fifth level</a:t>
             </a:r>
-            <a:endParaRPr lang="en-US"/>
           </a:p>
         </p:txBody>
       </p:sp>
@@ -1778,7 +1779,7 @@
           <a:p>
             <a:fld id="{5BCAD085-E8A6-8845-BD4E-CB4CCA059FC4}" type="datetimeFigureOut">
               <a:rPr lang="en-US" smtClean="0"/>
-              <a:t>1/27/13</a:t>
+              <a:t>3/24/2026</a:t>
             </a:fld>
             <a:endParaRPr lang="en-US"/>
           </a:p>
@@ -1820,7 +1821,7 @@
           <a:p>
             <a:fld id="{C1FF6DA9-008F-8B48-92A6-B652298478BF}" type="slidenum">
               <a:rPr lang="en-US" smtClean="0"/>
-              <a:t>‹#›</a:t>
+              <a:t>‹nr.›</a:t>
             </a:fld>
             <a:endParaRPr lang="en-US"/>
           </a:p>
@@ -1872,10 +1873,9 @@
           <a:lstStyle/>
           <a:p>
             <a:r>
-              <a:rPr lang="en-US" smtClean="0"/>
+              <a:rPr lang="en-US"/>
               <a:t>Click to edit Master title style</a:t>
             </a:r>
-            <a:endParaRPr lang="en-US"/>
           </a:p>
         </p:txBody>
       </p:sp>
@@ -1896,7 +1896,7 @@
           <a:p>
             <a:fld id="{5BCAD085-E8A6-8845-BD4E-CB4CCA059FC4}" type="datetimeFigureOut">
               <a:rPr lang="en-US" smtClean="0"/>
-              <a:t>1/27/13</a:t>
+              <a:t>3/24/2026</a:t>
             </a:fld>
             <a:endParaRPr lang="en-US"/>
           </a:p>
@@ -1938,7 +1938,7 @@
           <a:p>
             <a:fld id="{C1FF6DA9-008F-8B48-92A6-B652298478BF}" type="slidenum">
               <a:rPr lang="en-US" smtClean="0"/>
-              <a:t>‹#›</a:t>
+              <a:t>‹nr.›</a:t>
             </a:fld>
             <a:endParaRPr lang="en-US"/>
           </a:p>
@@ -1991,7 +1991,7 @@
           <a:p>
             <a:fld id="{5BCAD085-E8A6-8845-BD4E-CB4CCA059FC4}" type="datetimeFigureOut">
               <a:rPr lang="en-US" smtClean="0"/>
-              <a:t>1/27/13</a:t>
+              <a:t>3/24/2026</a:t>
             </a:fld>
             <a:endParaRPr lang="en-US"/>
           </a:p>
@@ -2033,7 +2033,7 @@
           <a:p>
             <a:fld id="{C1FF6DA9-008F-8B48-92A6-B652298478BF}" type="slidenum">
               <a:rPr lang="en-US" smtClean="0"/>
-              <a:t>‹#›</a:t>
+              <a:t>‹nr.›</a:t>
             </a:fld>
             <a:endParaRPr lang="en-US"/>
           </a:p>
@@ -2094,10 +2094,9 @@
           </a:lstStyle>
           <a:p>
             <a:r>
-              <a:rPr lang="en-US" smtClean="0"/>
+              <a:rPr lang="en-US"/>
               <a:t>Click to edit Master title style</a:t>
             </a:r>
-            <a:endParaRPr lang="en-US"/>
           </a:p>
         </p:txBody>
       </p:sp>
@@ -2151,38 +2150,37 @@
           <a:p>
             <a:pPr lvl="0"/>
             <a:r>
-              <a:rPr lang="en-US" smtClean="0"/>
+              <a:rPr lang="en-US"/>
               <a:t>Click to edit Master text styles</a:t>
             </a:r>
           </a:p>
           <a:p>
             <a:pPr lvl="1"/>
             <a:r>
-              <a:rPr lang="en-US" smtClean="0"/>
+              <a:rPr lang="en-US"/>
               <a:t>Second level</a:t>
             </a:r>
           </a:p>
           <a:p>
             <a:pPr lvl="2"/>
             <a:r>
-              <a:rPr lang="en-US" smtClean="0"/>
+              <a:rPr lang="en-US"/>
               <a:t>Third level</a:t>
             </a:r>
           </a:p>
           <a:p>
             <a:pPr lvl="3"/>
             <a:r>
-              <a:rPr lang="en-US" smtClean="0"/>
+              <a:rPr lang="en-US"/>
               <a:t>Fourth level</a:t>
             </a:r>
           </a:p>
           <a:p>
             <a:pPr lvl="4"/>
             <a:r>
-              <a:rPr lang="en-US" smtClean="0"/>
+              <a:rPr lang="en-US"/>
               <a:t>Fifth level</a:t>
             </a:r>
-            <a:endParaRPr lang="en-US"/>
           </a:p>
         </p:txBody>
       </p:sp>
@@ -2245,7 +2243,7 @@
           <a:p>
             <a:pPr lvl="0"/>
             <a:r>
-              <a:rPr lang="en-US" smtClean="0"/>
+              <a:rPr lang="en-US"/>
               <a:t>Click to edit Master text styles</a:t>
             </a:r>
           </a:p>
@@ -2268,7 +2266,7 @@
           <a:p>
             <a:fld id="{5BCAD085-E8A6-8845-BD4E-CB4CCA059FC4}" type="datetimeFigureOut">
               <a:rPr lang="en-US" smtClean="0"/>
-              <a:t>1/27/13</a:t>
+              <a:t>3/24/2026</a:t>
             </a:fld>
             <a:endParaRPr lang="en-US"/>
           </a:p>
@@ -2310,7 +2308,7 @@
           <a:p>
             <a:fld id="{C1FF6DA9-008F-8B48-92A6-B652298478BF}" type="slidenum">
               <a:rPr lang="en-US" smtClean="0"/>
-              <a:t>‹#›</a:t>
+              <a:t>‹nr.›</a:t>
             </a:fld>
             <a:endParaRPr lang="en-US"/>
           </a:p>
@@ -2371,10 +2369,9 @@
           </a:lstStyle>
           <a:p>
             <a:r>
-              <a:rPr lang="en-US" smtClean="0"/>
+              <a:rPr lang="en-US"/>
               <a:t>Click to edit Master title style</a:t>
             </a:r>
-            <a:endParaRPr lang="en-US"/>
           </a:p>
         </p:txBody>
       </p:sp>
@@ -2498,7 +2495,7 @@
           <a:p>
             <a:pPr lvl="0"/>
             <a:r>
-              <a:rPr lang="en-US" smtClean="0"/>
+              <a:rPr lang="en-US"/>
               <a:t>Click to edit Master text styles</a:t>
             </a:r>
           </a:p>
@@ -2521,7 +2518,7 @@
           <a:p>
             <a:fld id="{5BCAD085-E8A6-8845-BD4E-CB4CCA059FC4}" type="datetimeFigureOut">
               <a:rPr lang="en-US" smtClean="0"/>
-              <a:t>1/27/13</a:t>
+              <a:t>3/24/2026</a:t>
             </a:fld>
             <a:endParaRPr lang="en-US"/>
           </a:p>
@@ -2563,7 +2560,7 @@
           <a:p>
             <a:fld id="{C1FF6DA9-008F-8B48-92A6-B652298478BF}" type="slidenum">
               <a:rPr lang="en-US" smtClean="0"/>
-              <a:t>‹#›</a:t>
+              <a:t>‹nr.›</a:t>
             </a:fld>
             <a:endParaRPr lang="en-US"/>
           </a:p>
@@ -2630,10 +2627,9 @@
           <a:lstStyle/>
           <a:p>
             <a:r>
-              <a:rPr lang="en-US" smtClean="0"/>
+              <a:rPr lang="en-US"/>
               <a:t>Click to edit Master title style</a:t>
             </a:r>
-            <a:endParaRPr lang="en-US"/>
           </a:p>
         </p:txBody>
       </p:sp>
@@ -2664,38 +2660,37 @@
           <a:p>
             <a:pPr lvl="0"/>
             <a:r>
-              <a:rPr lang="en-US" smtClean="0"/>
+              <a:rPr lang="en-US"/>
               <a:t>Click to edit Master text styles</a:t>
             </a:r>
           </a:p>
           <a:p>
             <a:pPr lvl="1"/>
             <a:r>
-              <a:rPr lang="en-US" smtClean="0"/>
+              <a:rPr lang="en-US"/>
               <a:t>Second level</a:t>
             </a:r>
           </a:p>
           <a:p>
             <a:pPr lvl="2"/>
             <a:r>
-              <a:rPr lang="en-US" smtClean="0"/>
+              <a:rPr lang="en-US"/>
               <a:t>Third level</a:t>
             </a:r>
           </a:p>
           <a:p>
             <a:pPr lvl="3"/>
             <a:r>
-              <a:rPr lang="en-US" smtClean="0"/>
+              <a:rPr lang="en-US"/>
               <a:t>Fourth level</a:t>
             </a:r>
           </a:p>
           <a:p>
             <a:pPr lvl="4"/>
             <a:r>
-              <a:rPr lang="en-US" smtClean="0"/>
+              <a:rPr lang="en-US"/>
               <a:t>Fifth level</a:t>
             </a:r>
-            <a:endParaRPr lang="en-US"/>
           </a:p>
         </p:txBody>
       </p:sp>
@@ -2734,7 +2729,7 @@
           <a:p>
             <a:fld id="{5BCAD085-E8A6-8845-BD4E-CB4CCA059FC4}" type="datetimeFigureOut">
               <a:rPr lang="en-US" smtClean="0"/>
-              <a:t>1/27/13</a:t>
+              <a:t>3/24/2026</a:t>
             </a:fld>
             <a:endParaRPr lang="en-US"/>
           </a:p>
@@ -2812,7 +2807,7 @@
           <a:p>
             <a:fld id="{C1FF6DA9-008F-8B48-92A6-B652298478BF}" type="slidenum">
               <a:rPr lang="en-US" smtClean="0"/>
-              <a:t>‹#›</a:t>
+              <a:t>‹nr.›</a:t>
             </a:fld>
             <a:endParaRPr lang="en-US"/>
           </a:p>
@@ -3093,7 +3088,7 @@
 </file>
 
 <file path=ppt/slides/slide1.xml><?xml version="1.0" encoding="utf-8"?>
-<p:sld xmlns:a="http://schemas.openxmlformats.org/drawingml/2006/main" xmlns:p="http://schemas.openxmlformats.org/presentationml/2006/main" xmlns:r="http://schemas.openxmlformats.org/officeDocument/2006/relationships">
+<p:sld xmlns:a="http://schemas.openxmlformats.org/drawingml/2006/main" xmlns:r="http://schemas.openxmlformats.org/officeDocument/2006/relationships" xmlns:p="http://schemas.openxmlformats.org/presentationml/2006/main">
   <p:cSld>
     <p:bg>
       <p:bgPr>
@@ -3109,7 +3104,14 @@
         <p:cNvGrpSpPr/>
         <p:nvPr/>
       </p:nvGrpSpPr>
-      <p:grpSpPr/>
+      <p:grpSpPr>
+        <a:xfrm>
+          <a:off x="0" y="0"/>
+          <a:ext cx="0" cy="0"/>
+          <a:chOff x="0" y="0"/>
+          <a:chExt cx="0" cy="0"/>
+        </a:xfrm>
+      </p:grpSpPr>
       <p:sp>
         <p:nvSpPr>
           <p:cNvPr id="2" name="Oval 1"/>
@@ -3150,6 +3152,7 @@
           <a:lstStyle/>
           <a:p>
             <a:pPr algn="ctr"/>
+            <a:endParaRPr/>
           </a:p>
         </p:txBody>
       </p:sp>
@@ -3193,6 +3196,7 @@
           <a:lstStyle/>
           <a:p>
             <a:pPr algn="ctr"/>
+            <a:endParaRPr/>
           </a:p>
         </p:txBody>
       </p:sp>
@@ -3236,6 +3240,7 @@
           <a:lstStyle/>
           <a:p>
             <a:pPr algn="ctr"/>
+            <a:endParaRPr/>
           </a:p>
         </p:txBody>
       </p:sp>
@@ -3279,6 +3284,7 @@
           <a:lstStyle/>
           <a:p>
             <a:pPr algn="ctr"/>
+            <a:endParaRPr/>
           </a:p>
         </p:txBody>
       </p:sp>
@@ -3322,6 +3328,7 @@
           <a:lstStyle/>
           <a:p>
             <a:pPr algn="ctr"/>
+            <a:endParaRPr/>
           </a:p>
         </p:txBody>
       </p:sp>
@@ -3439,7 +3446,7 @@
 </file>
 
 <file path=ppt/slides/slide10.xml><?xml version="1.0" encoding="utf-8"?>
-<p:sld xmlns:a="http://schemas.openxmlformats.org/drawingml/2006/main" xmlns:p="http://schemas.openxmlformats.org/presentationml/2006/main" xmlns:r="http://schemas.openxmlformats.org/officeDocument/2006/relationships">
+<p:sld xmlns:a="http://schemas.openxmlformats.org/drawingml/2006/main" xmlns:r="http://schemas.openxmlformats.org/officeDocument/2006/relationships" xmlns:p="http://schemas.openxmlformats.org/presentationml/2006/main">
   <p:cSld>
     <p:bg>
       <p:bgPr>
@@ -3455,7 +3462,14 @@
         <p:cNvGrpSpPr/>
         <p:nvPr/>
       </p:nvGrpSpPr>
-      <p:grpSpPr/>
+      <p:grpSpPr>
+        <a:xfrm>
+          <a:off x="0" y="0"/>
+          <a:ext cx="0" cy="0"/>
+          <a:chOff x="0" y="0"/>
+          <a:chExt cx="0" cy="0"/>
+        </a:xfrm>
+      </p:grpSpPr>
       <p:sp>
         <p:nvSpPr>
           <p:cNvPr id="2" name="Rectangle 1"/>
@@ -3496,6 +3510,7 @@
           <a:lstStyle/>
           <a:p>
             <a:pPr algn="ctr"/>
+            <a:endParaRPr/>
           </a:p>
         </p:txBody>
       </p:sp>
@@ -3539,6 +3554,7 @@
           <a:lstStyle/>
           <a:p>
             <a:pPr algn="ctr"/>
+            <a:endParaRPr/>
           </a:p>
         </p:txBody>
       </p:sp>
@@ -3617,6 +3633,7 @@
           <a:lstStyle/>
           <a:p>
             <a:pPr algn="ctr"/>
+            <a:endParaRPr/>
           </a:p>
         </p:txBody>
       </p:sp>
@@ -3814,6 +3831,7 @@
           <a:lstStyle/>
           <a:p>
             <a:pPr algn="ctr"/>
+            <a:endParaRPr/>
           </a:p>
         </p:txBody>
       </p:sp>
@@ -3964,7 +3982,7 @@
 </file>
 
 <file path=ppt/slides/slide11.xml><?xml version="1.0" encoding="utf-8"?>
-<p:sld xmlns:a="http://schemas.openxmlformats.org/drawingml/2006/main" xmlns:p="http://schemas.openxmlformats.org/presentationml/2006/main" xmlns:r="http://schemas.openxmlformats.org/officeDocument/2006/relationships">
+<p:sld xmlns:a="http://schemas.openxmlformats.org/drawingml/2006/main" xmlns:r="http://schemas.openxmlformats.org/officeDocument/2006/relationships" xmlns:p="http://schemas.openxmlformats.org/presentationml/2006/main">
   <p:cSld>
     <p:bg>
       <p:bgPr>
@@ -3980,7 +3998,14 @@
         <p:cNvGrpSpPr/>
         <p:nvPr/>
       </p:nvGrpSpPr>
-      <p:grpSpPr/>
+      <p:grpSpPr>
+        <a:xfrm>
+          <a:off x="0" y="0"/>
+          <a:ext cx="0" cy="0"/>
+          <a:chOff x="0" y="0"/>
+          <a:chExt cx="0" cy="0"/>
+        </a:xfrm>
+      </p:grpSpPr>
       <p:sp>
         <p:nvSpPr>
           <p:cNvPr id="2" name="Rectangle 1"/>
@@ -4021,6 +4046,7 @@
           <a:lstStyle/>
           <a:p>
             <a:pPr algn="ctr"/>
+            <a:endParaRPr/>
           </a:p>
         </p:txBody>
       </p:sp>
@@ -4064,6 +4090,7 @@
           <a:lstStyle/>
           <a:p>
             <a:pPr algn="ctr"/>
+            <a:endParaRPr/>
           </a:p>
         </p:txBody>
       </p:sp>
@@ -4142,6 +4169,7 @@
           <a:lstStyle/>
           <a:p>
             <a:pPr algn="ctr"/>
+            <a:endParaRPr/>
           </a:p>
         </p:txBody>
       </p:sp>
@@ -4291,6 +4319,7 @@
           <a:lstStyle/>
           <a:p>
             <a:pPr algn="ctr"/>
+            <a:endParaRPr/>
           </a:p>
         </p:txBody>
       </p:sp>
@@ -4536,6 +4565,7 @@
           <a:lstStyle/>
           <a:p>
             <a:pPr algn="ctr"/>
+            <a:endParaRPr/>
           </a:p>
         </p:txBody>
       </p:sp>
@@ -4788,7 +4818,7 @@
 </file>
 
 <file path=ppt/slides/slide12.xml><?xml version="1.0" encoding="utf-8"?>
-<p:sld xmlns:a="http://schemas.openxmlformats.org/drawingml/2006/main" xmlns:p="http://schemas.openxmlformats.org/presentationml/2006/main" xmlns:r="http://schemas.openxmlformats.org/officeDocument/2006/relationships">
+<p:sld xmlns:a="http://schemas.openxmlformats.org/drawingml/2006/main" xmlns:r="http://schemas.openxmlformats.org/officeDocument/2006/relationships" xmlns:p="http://schemas.openxmlformats.org/presentationml/2006/main">
   <p:cSld>
     <p:bg>
       <p:bgPr>
@@ -4804,7 +4834,14 @@
         <p:cNvGrpSpPr/>
         <p:nvPr/>
       </p:nvGrpSpPr>
-      <p:grpSpPr/>
+      <p:grpSpPr>
+        <a:xfrm>
+          <a:off x="0" y="0"/>
+          <a:ext cx="0" cy="0"/>
+          <a:chOff x="0" y="0"/>
+          <a:chExt cx="0" cy="0"/>
+        </a:xfrm>
+      </p:grpSpPr>
       <p:sp>
         <p:nvSpPr>
           <p:cNvPr id="2" name="Rectangle 1"/>
@@ -4845,6 +4882,7 @@
           <a:lstStyle/>
           <a:p>
             <a:pPr algn="ctr"/>
+            <a:endParaRPr/>
           </a:p>
         </p:txBody>
       </p:sp>
@@ -4888,6 +4926,7 @@
           <a:lstStyle/>
           <a:p>
             <a:pPr algn="ctr"/>
+            <a:endParaRPr/>
           </a:p>
         </p:txBody>
       </p:sp>
@@ -4966,6 +5005,7 @@
           <a:lstStyle/>
           <a:p>
             <a:pPr algn="ctr"/>
+            <a:endParaRPr/>
           </a:p>
         </p:txBody>
       </p:sp>
@@ -5079,6 +5119,7 @@
           <a:lstStyle/>
           <a:p>
             <a:pPr algn="ctr"/>
+            <a:endParaRPr/>
           </a:p>
         </p:txBody>
       </p:sp>
@@ -5192,6 +5233,7 @@
           <a:lstStyle/>
           <a:p>
             <a:pPr algn="ctr"/>
+            <a:endParaRPr/>
           </a:p>
         </p:txBody>
       </p:sp>
@@ -5305,6 +5347,7 @@
           <a:lstStyle/>
           <a:p>
             <a:pPr algn="ctr"/>
+            <a:endParaRPr/>
           </a:p>
         </p:txBody>
       </p:sp>
@@ -5418,6 +5461,7 @@
           <a:lstStyle/>
           <a:p>
             <a:pPr algn="ctr"/>
+            <a:endParaRPr/>
           </a:p>
         </p:txBody>
       </p:sp>
@@ -5500,7 +5544,7 @@
 </file>
 
 <file path=ppt/slides/slide13.xml><?xml version="1.0" encoding="utf-8"?>
-<p:sld xmlns:a="http://schemas.openxmlformats.org/drawingml/2006/main" xmlns:p="http://schemas.openxmlformats.org/presentationml/2006/main" xmlns:r="http://schemas.openxmlformats.org/officeDocument/2006/relationships">
+<p:sld xmlns:a="http://schemas.openxmlformats.org/drawingml/2006/main" xmlns:r="http://schemas.openxmlformats.org/officeDocument/2006/relationships" xmlns:p="http://schemas.openxmlformats.org/presentationml/2006/main">
   <p:cSld>
     <p:bg>
       <p:bgPr>
@@ -5516,7 +5560,14 @@
         <p:cNvGrpSpPr/>
         <p:nvPr/>
       </p:nvGrpSpPr>
-      <p:grpSpPr/>
+      <p:grpSpPr>
+        <a:xfrm>
+          <a:off x="0" y="0"/>
+          <a:ext cx="0" cy="0"/>
+          <a:chOff x="0" y="0"/>
+          <a:chExt cx="0" cy="0"/>
+        </a:xfrm>
+      </p:grpSpPr>
       <p:sp>
         <p:nvSpPr>
           <p:cNvPr id="2" name="Rectangle 1"/>
@@ -5557,6 +5608,7 @@
           <a:lstStyle/>
           <a:p>
             <a:pPr algn="ctr"/>
+            <a:endParaRPr/>
           </a:p>
         </p:txBody>
       </p:sp>
@@ -5600,6 +5652,7 @@
           <a:lstStyle/>
           <a:p>
             <a:pPr algn="ctr"/>
+            <a:endParaRPr/>
           </a:p>
         </p:txBody>
       </p:sp>
@@ -5678,6 +5731,7 @@
           <a:lstStyle/>
           <a:p>
             <a:pPr algn="ctr"/>
+            <a:endParaRPr/>
           </a:p>
         </p:txBody>
       </p:sp>
@@ -5756,6 +5810,7 @@
           <a:lstStyle/>
           <a:p>
             <a:pPr algn="ctr"/>
+            <a:endParaRPr/>
           </a:p>
         </p:txBody>
       </p:sp>
@@ -5834,6 +5889,7 @@
           <a:lstStyle/>
           <a:p>
             <a:pPr algn="ctr"/>
+            <a:endParaRPr/>
           </a:p>
         </p:txBody>
       </p:sp>
@@ -5880,8 +5936,8 @@
         </p:nvSpPr>
         <p:spPr>
           <a:xfrm>
-            <a:off x="365760" y="1444752"/>
-            <a:ext cx="3108960" cy="347472"/>
+            <a:off x="365760" y="1473384"/>
+            <a:ext cx="3108960" cy="462485"/>
           </a:xfrm>
           <a:prstGeom prst="rect">
             <a:avLst/>
@@ -5912,6 +5968,7 @@
           <a:lstStyle/>
           <a:p>
             <a:pPr algn="ctr"/>
+            <a:endParaRPr/>
           </a:p>
         </p:txBody>
       </p:sp>
@@ -5958,8 +6015,8 @@
         </p:nvSpPr>
         <p:spPr>
           <a:xfrm>
-            <a:off x="3474720" y="1444752"/>
-            <a:ext cx="4114800" cy="347472"/>
+            <a:off x="3474720" y="1473384"/>
+            <a:ext cx="4114800" cy="462485"/>
           </a:xfrm>
           <a:prstGeom prst="rect">
             <a:avLst/>
@@ -5990,6 +6047,7 @@
           <a:lstStyle/>
           <a:p>
             <a:pPr algn="ctr"/>
+            <a:endParaRPr/>
           </a:p>
         </p:txBody>
       </p:sp>
@@ -6036,8 +6094,8 @@
         </p:nvSpPr>
         <p:spPr>
           <a:xfrm>
-            <a:off x="7589520" y="1444752"/>
-            <a:ext cx="4114800" cy="347472"/>
+            <a:off x="7589520" y="1473384"/>
+            <a:ext cx="4114800" cy="462485"/>
           </a:xfrm>
           <a:prstGeom prst="rect">
             <a:avLst/>
@@ -6068,6 +6126,7 @@
           <a:lstStyle/>
           <a:p>
             <a:pPr algn="ctr"/>
+            <a:endParaRPr/>
           </a:p>
         </p:txBody>
       </p:sp>
@@ -6114,8 +6173,8 @@
         </p:nvSpPr>
         <p:spPr>
           <a:xfrm>
-            <a:off x="365760" y="1792224"/>
-            <a:ext cx="3108960" cy="347472"/>
+            <a:off x="365760" y="1960002"/>
+            <a:ext cx="3108960" cy="462485"/>
           </a:xfrm>
           <a:prstGeom prst="rect">
             <a:avLst/>
@@ -6146,6 +6205,7 @@
           <a:lstStyle/>
           <a:p>
             <a:pPr algn="ctr"/>
+            <a:endParaRPr/>
           </a:p>
         </p:txBody>
       </p:sp>
@@ -6157,8 +6217,8 @@
         </p:nvSpPr>
         <p:spPr>
           <a:xfrm>
-            <a:off x="438912" y="1837944"/>
-            <a:ext cx="3017520" cy="301752"/>
+            <a:off x="438912" y="1970145"/>
+            <a:ext cx="3017520" cy="249382"/>
           </a:xfrm>
           <a:prstGeom prst="rect">
             <a:avLst/>
@@ -6192,8 +6252,8 @@
         </p:nvSpPr>
         <p:spPr>
           <a:xfrm>
-            <a:off x="3474720" y="1792224"/>
-            <a:ext cx="4114800" cy="347472"/>
+            <a:off x="3474720" y="1960002"/>
+            <a:ext cx="4114800" cy="462485"/>
           </a:xfrm>
           <a:prstGeom prst="rect">
             <a:avLst/>
@@ -6224,6 +6284,7 @@
           <a:lstStyle/>
           <a:p>
             <a:pPr algn="ctr"/>
+            <a:endParaRPr/>
           </a:p>
         </p:txBody>
       </p:sp>
@@ -6235,8 +6296,8 @@
         </p:nvSpPr>
         <p:spPr>
           <a:xfrm>
-            <a:off x="3547872" y="1837944"/>
-            <a:ext cx="4023360" cy="301752"/>
+            <a:off x="3547872" y="1970145"/>
+            <a:ext cx="4023360" cy="249382"/>
           </a:xfrm>
           <a:prstGeom prst="rect">
             <a:avLst/>
@@ -6270,8 +6331,8 @@
         </p:nvSpPr>
         <p:spPr>
           <a:xfrm>
-            <a:off x="7589520" y="1792224"/>
-            <a:ext cx="4114800" cy="347472"/>
+            <a:off x="7589520" y="1960002"/>
+            <a:ext cx="4114800" cy="462485"/>
           </a:xfrm>
           <a:prstGeom prst="rect">
             <a:avLst/>
@@ -6302,6 +6363,7 @@
           <a:lstStyle/>
           <a:p>
             <a:pPr algn="ctr"/>
+            <a:endParaRPr/>
           </a:p>
         </p:txBody>
       </p:sp>
@@ -6313,8 +6375,8 @@
         </p:nvSpPr>
         <p:spPr>
           <a:xfrm>
-            <a:off x="7662672" y="1837944"/>
-            <a:ext cx="4023360" cy="301752"/>
+            <a:off x="7662672" y="1970145"/>
+            <a:ext cx="4023360" cy="249382"/>
           </a:xfrm>
           <a:prstGeom prst="rect">
             <a:avLst/>
@@ -6348,7 +6410,7 @@
         </p:nvSpPr>
         <p:spPr>
           <a:xfrm>
-            <a:off x="365760" y="2139696"/>
+            <a:off x="365760" y="2404736"/>
             <a:ext cx="3108960" cy="347472"/>
           </a:xfrm>
           <a:prstGeom prst="rect">
@@ -6380,6 +6442,7 @@
           <a:lstStyle/>
           <a:p>
             <a:pPr algn="ctr"/>
+            <a:endParaRPr/>
           </a:p>
         </p:txBody>
       </p:sp>
@@ -6391,7 +6454,7 @@
         </p:nvSpPr>
         <p:spPr>
           <a:xfrm>
-            <a:off x="438912" y="2185416"/>
+            <a:off x="438912" y="2450456"/>
             <a:ext cx="3017520" cy="301752"/>
           </a:xfrm>
           <a:prstGeom prst="rect">
@@ -6426,7 +6489,7 @@
         </p:nvSpPr>
         <p:spPr>
           <a:xfrm>
-            <a:off x="3474720" y="2139696"/>
+            <a:off x="3474720" y="2404736"/>
             <a:ext cx="4114800" cy="347472"/>
           </a:xfrm>
           <a:prstGeom prst="rect">
@@ -6458,6 +6521,7 @@
           <a:lstStyle/>
           <a:p>
             <a:pPr algn="ctr"/>
+            <a:endParaRPr/>
           </a:p>
         </p:txBody>
       </p:sp>
@@ -6469,7 +6533,7 @@
         </p:nvSpPr>
         <p:spPr>
           <a:xfrm>
-            <a:off x="3547872" y="2185416"/>
+            <a:off x="3547872" y="2450456"/>
             <a:ext cx="4023360" cy="301752"/>
           </a:xfrm>
           <a:prstGeom prst="rect">
@@ -6504,7 +6568,7 @@
         </p:nvSpPr>
         <p:spPr>
           <a:xfrm>
-            <a:off x="7589520" y="2139696"/>
+            <a:off x="7589520" y="2404736"/>
             <a:ext cx="4114800" cy="347472"/>
           </a:xfrm>
           <a:prstGeom prst="rect">
@@ -6536,6 +6600,7 @@
           <a:lstStyle/>
           <a:p>
             <a:pPr algn="ctr"/>
+            <a:endParaRPr/>
           </a:p>
         </p:txBody>
       </p:sp>
@@ -6547,7 +6612,7 @@
         </p:nvSpPr>
         <p:spPr>
           <a:xfrm>
-            <a:off x="7662672" y="2185416"/>
+            <a:off x="7662672" y="2450456"/>
             <a:ext cx="4023360" cy="301752"/>
           </a:xfrm>
           <a:prstGeom prst="rect">
@@ -6582,7 +6647,7 @@
         </p:nvSpPr>
         <p:spPr>
           <a:xfrm>
-            <a:off x="365760" y="2487168"/>
+            <a:off x="365760" y="2752208"/>
             <a:ext cx="3108960" cy="347472"/>
           </a:xfrm>
           <a:prstGeom prst="rect">
@@ -6614,6 +6679,7 @@
           <a:lstStyle/>
           <a:p>
             <a:pPr algn="ctr"/>
+            <a:endParaRPr/>
           </a:p>
         </p:txBody>
       </p:sp>
@@ -6625,7 +6691,7 @@
         </p:nvSpPr>
         <p:spPr>
           <a:xfrm>
-            <a:off x="438912" y="2532888"/>
+            <a:off x="438912" y="2797928"/>
             <a:ext cx="3017520" cy="301752"/>
           </a:xfrm>
           <a:prstGeom prst="rect">
@@ -6660,7 +6726,7 @@
         </p:nvSpPr>
         <p:spPr>
           <a:xfrm>
-            <a:off x="3474720" y="2487168"/>
+            <a:off x="3474720" y="2752208"/>
             <a:ext cx="4114800" cy="347472"/>
           </a:xfrm>
           <a:prstGeom prst="rect">
@@ -6692,6 +6758,7 @@
           <a:lstStyle/>
           <a:p>
             <a:pPr algn="ctr"/>
+            <a:endParaRPr/>
           </a:p>
         </p:txBody>
       </p:sp>
@@ -6703,7 +6770,7 @@
         </p:nvSpPr>
         <p:spPr>
           <a:xfrm>
-            <a:off x="3547872" y="2532888"/>
+            <a:off x="3547872" y="2797928"/>
             <a:ext cx="4023360" cy="301752"/>
           </a:xfrm>
           <a:prstGeom prst="rect">
@@ -6738,7 +6805,7 @@
         </p:nvSpPr>
         <p:spPr>
           <a:xfrm>
-            <a:off x="7589520" y="2487168"/>
+            <a:off x="7589520" y="2752208"/>
             <a:ext cx="4114800" cy="347472"/>
           </a:xfrm>
           <a:prstGeom prst="rect">
@@ -6770,6 +6837,7 @@
           <a:lstStyle/>
           <a:p>
             <a:pPr algn="ctr"/>
+            <a:endParaRPr/>
           </a:p>
         </p:txBody>
       </p:sp>
@@ -6781,7 +6849,7 @@
         </p:nvSpPr>
         <p:spPr>
           <a:xfrm>
-            <a:off x="7662672" y="2532888"/>
+            <a:off x="7662672" y="2797928"/>
             <a:ext cx="4023360" cy="301752"/>
           </a:xfrm>
           <a:prstGeom prst="rect">
@@ -6816,7 +6884,7 @@
         </p:nvSpPr>
         <p:spPr>
           <a:xfrm>
-            <a:off x="365760" y="2834640"/>
+            <a:off x="365760" y="3099680"/>
             <a:ext cx="3108960" cy="347472"/>
           </a:xfrm>
           <a:prstGeom prst="rect">
@@ -6848,6 +6916,7 @@
           <a:lstStyle/>
           <a:p>
             <a:pPr algn="ctr"/>
+            <a:endParaRPr/>
           </a:p>
         </p:txBody>
       </p:sp>
@@ -6859,7 +6928,7 @@
         </p:nvSpPr>
         <p:spPr>
           <a:xfrm>
-            <a:off x="438912" y="2880360"/>
+            <a:off x="438912" y="3145400"/>
             <a:ext cx="3017520" cy="301752"/>
           </a:xfrm>
           <a:prstGeom prst="rect">
@@ -6894,7 +6963,7 @@
         </p:nvSpPr>
         <p:spPr>
           <a:xfrm>
-            <a:off x="3474720" y="2834640"/>
+            <a:off x="3474720" y="3099680"/>
             <a:ext cx="4114800" cy="347472"/>
           </a:xfrm>
           <a:prstGeom prst="rect">
@@ -6926,6 +6995,7 @@
           <a:lstStyle/>
           <a:p>
             <a:pPr algn="ctr"/>
+            <a:endParaRPr/>
           </a:p>
         </p:txBody>
       </p:sp>
@@ -6937,7 +7007,7 @@
         </p:nvSpPr>
         <p:spPr>
           <a:xfrm>
-            <a:off x="3547872" y="2880360"/>
+            <a:off x="3547872" y="3145400"/>
             <a:ext cx="4023360" cy="301752"/>
           </a:xfrm>
           <a:prstGeom prst="rect">
@@ -6972,7 +7042,7 @@
         </p:nvSpPr>
         <p:spPr>
           <a:xfrm>
-            <a:off x="7589520" y="2834640"/>
+            <a:off x="7589520" y="3099680"/>
             <a:ext cx="4114800" cy="347472"/>
           </a:xfrm>
           <a:prstGeom prst="rect">
@@ -7004,6 +7074,7 @@
           <a:lstStyle/>
           <a:p>
             <a:pPr algn="ctr"/>
+            <a:endParaRPr/>
           </a:p>
         </p:txBody>
       </p:sp>
@@ -7015,7 +7086,7 @@
         </p:nvSpPr>
         <p:spPr>
           <a:xfrm>
-            <a:off x="7662672" y="2880360"/>
+            <a:off x="7662672" y="3145400"/>
             <a:ext cx="4023360" cy="301752"/>
           </a:xfrm>
           <a:prstGeom prst="rect">
@@ -7050,7 +7121,7 @@
         </p:nvSpPr>
         <p:spPr>
           <a:xfrm>
-            <a:off x="365760" y="3182112"/>
+            <a:off x="365760" y="3447152"/>
             <a:ext cx="3108960" cy="347472"/>
           </a:xfrm>
           <a:prstGeom prst="rect">
@@ -7082,6 +7153,7 @@
           <a:lstStyle/>
           <a:p>
             <a:pPr algn="ctr"/>
+            <a:endParaRPr/>
           </a:p>
         </p:txBody>
       </p:sp>
@@ -7093,7 +7165,7 @@
         </p:nvSpPr>
         <p:spPr>
           <a:xfrm>
-            <a:off x="438912" y="3227832"/>
+            <a:off x="438912" y="3492872"/>
             <a:ext cx="3017520" cy="301752"/>
           </a:xfrm>
           <a:prstGeom prst="rect">
@@ -7128,7 +7200,7 @@
         </p:nvSpPr>
         <p:spPr>
           <a:xfrm>
-            <a:off x="3474720" y="3182112"/>
+            <a:off x="3474720" y="3447152"/>
             <a:ext cx="4114800" cy="347472"/>
           </a:xfrm>
           <a:prstGeom prst="rect">
@@ -7160,6 +7232,7 @@
           <a:lstStyle/>
           <a:p>
             <a:pPr algn="ctr"/>
+            <a:endParaRPr/>
           </a:p>
         </p:txBody>
       </p:sp>
@@ -7171,7 +7244,7 @@
         </p:nvSpPr>
         <p:spPr>
           <a:xfrm>
-            <a:off x="3547872" y="3227832"/>
+            <a:off x="3547872" y="3492872"/>
             <a:ext cx="4023360" cy="301752"/>
           </a:xfrm>
           <a:prstGeom prst="rect">
@@ -7206,7 +7279,7 @@
         </p:nvSpPr>
         <p:spPr>
           <a:xfrm>
-            <a:off x="7589520" y="3182112"/>
+            <a:off x="7589520" y="3447152"/>
             <a:ext cx="4114800" cy="347472"/>
           </a:xfrm>
           <a:prstGeom prst="rect">
@@ -7238,6 +7311,7 @@
           <a:lstStyle/>
           <a:p>
             <a:pPr algn="ctr"/>
+            <a:endParaRPr/>
           </a:p>
         </p:txBody>
       </p:sp>
@@ -7249,7 +7323,7 @@
         </p:nvSpPr>
         <p:spPr>
           <a:xfrm>
-            <a:off x="7662672" y="3227832"/>
+            <a:off x="7662672" y="3492872"/>
             <a:ext cx="4023360" cy="301752"/>
           </a:xfrm>
           <a:prstGeom prst="rect">
@@ -7285,7 +7359,7 @@
 </file>
 
 <file path=ppt/slides/slide14.xml><?xml version="1.0" encoding="utf-8"?>
-<p:sld xmlns:a="http://schemas.openxmlformats.org/drawingml/2006/main" xmlns:p="http://schemas.openxmlformats.org/presentationml/2006/main" xmlns:r="http://schemas.openxmlformats.org/officeDocument/2006/relationships">
+<p:sld xmlns:a="http://schemas.openxmlformats.org/drawingml/2006/main" xmlns:r="http://schemas.openxmlformats.org/officeDocument/2006/relationships" xmlns:p="http://schemas.openxmlformats.org/presentationml/2006/main">
   <p:cSld>
     <p:bg>
       <p:bgPr>
@@ -7301,7 +7375,14 @@
         <p:cNvGrpSpPr/>
         <p:nvPr/>
       </p:nvGrpSpPr>
-      <p:grpSpPr/>
+      <p:grpSpPr>
+        <a:xfrm>
+          <a:off x="0" y="0"/>
+          <a:ext cx="0" cy="0"/>
+          <a:chOff x="0" y="0"/>
+          <a:chExt cx="0" cy="0"/>
+        </a:xfrm>
+      </p:grpSpPr>
       <p:sp>
         <p:nvSpPr>
           <p:cNvPr id="2" name="Rectangle 1"/>
@@ -7342,6 +7423,7 @@
           <a:lstStyle/>
           <a:p>
             <a:pPr algn="ctr"/>
+            <a:endParaRPr/>
           </a:p>
         </p:txBody>
       </p:sp>
@@ -7385,6 +7467,7 @@
           <a:lstStyle/>
           <a:p>
             <a:pPr algn="ctr"/>
+            <a:endParaRPr/>
           </a:p>
         </p:txBody>
       </p:sp>
@@ -7463,6 +7546,7 @@
           <a:lstStyle/>
           <a:p>
             <a:pPr algn="ctr"/>
+            <a:endParaRPr/>
           </a:p>
         </p:txBody>
       </p:sp>
@@ -7541,6 +7625,7 @@
           <a:lstStyle/>
           <a:p>
             <a:pPr algn="ctr"/>
+            <a:endParaRPr/>
           </a:p>
         </p:txBody>
       </p:sp>
@@ -7619,6 +7704,7 @@
           <a:lstStyle/>
           <a:p>
             <a:pPr algn="ctr"/>
+            <a:endParaRPr/>
           </a:p>
         </p:txBody>
       </p:sp>
@@ -7697,6 +7783,7 @@
           <a:lstStyle/>
           <a:p>
             <a:pPr algn="ctr"/>
+            <a:endParaRPr/>
           </a:p>
         </p:txBody>
       </p:sp>
@@ -7775,6 +7862,7 @@
           <a:lstStyle/>
           <a:p>
             <a:pPr algn="ctr"/>
+            <a:endParaRPr/>
           </a:p>
         </p:txBody>
       </p:sp>
@@ -7853,6 +7941,7 @@
           <a:lstStyle/>
           <a:p>
             <a:pPr algn="ctr"/>
+            <a:endParaRPr/>
           </a:p>
         </p:txBody>
       </p:sp>
@@ -7931,6 +8020,7 @@
           <a:lstStyle/>
           <a:p>
             <a:pPr algn="ctr"/>
+            <a:endParaRPr/>
           </a:p>
         </p:txBody>
       </p:sp>
@@ -8009,6 +8099,7 @@
           <a:lstStyle/>
           <a:p>
             <a:pPr algn="ctr"/>
+            <a:endParaRPr/>
           </a:p>
         </p:txBody>
       </p:sp>
@@ -8087,6 +8178,7 @@
           <a:lstStyle/>
           <a:p>
             <a:pPr algn="ctr"/>
+            <a:endParaRPr/>
           </a:p>
         </p:txBody>
       </p:sp>
@@ -8165,6 +8257,7 @@
           <a:lstStyle/>
           <a:p>
             <a:pPr algn="ctr"/>
+            <a:endParaRPr/>
           </a:p>
         </p:txBody>
       </p:sp>
@@ -8243,6 +8336,7 @@
           <a:lstStyle/>
           <a:p>
             <a:pPr algn="ctr"/>
+            <a:endParaRPr/>
           </a:p>
         </p:txBody>
       </p:sp>
@@ -8321,6 +8415,7 @@
           <a:lstStyle/>
           <a:p>
             <a:pPr algn="ctr"/>
+            <a:endParaRPr/>
           </a:p>
         </p:txBody>
       </p:sp>
@@ -8399,6 +8494,7 @@
           <a:lstStyle/>
           <a:p>
             <a:pPr algn="ctr"/>
+            <a:endParaRPr/>
           </a:p>
         </p:txBody>
       </p:sp>
@@ -8477,6 +8573,7 @@
           <a:lstStyle/>
           <a:p>
             <a:pPr algn="ctr"/>
+            <a:endParaRPr/>
           </a:p>
         </p:txBody>
       </p:sp>
@@ -8555,6 +8652,7 @@
           <a:lstStyle/>
           <a:p>
             <a:pPr algn="ctr"/>
+            <a:endParaRPr/>
           </a:p>
         </p:txBody>
       </p:sp>
@@ -8633,6 +8731,7 @@
           <a:lstStyle/>
           <a:p>
             <a:pPr algn="ctr"/>
+            <a:endParaRPr/>
           </a:p>
         </p:txBody>
       </p:sp>
@@ -8711,6 +8810,7 @@
           <a:lstStyle/>
           <a:p>
             <a:pPr algn="ctr"/>
+            <a:endParaRPr/>
           </a:p>
         </p:txBody>
       </p:sp>
@@ -8789,6 +8889,7 @@
           <a:lstStyle/>
           <a:p>
             <a:pPr algn="ctr"/>
+            <a:endParaRPr/>
           </a:p>
         </p:txBody>
       </p:sp>
@@ -8867,6 +8968,7 @@
           <a:lstStyle/>
           <a:p>
             <a:pPr algn="ctr"/>
+            <a:endParaRPr/>
           </a:p>
         </p:txBody>
       </p:sp>
@@ -8945,6 +9047,7 @@
           <a:lstStyle/>
           <a:p>
             <a:pPr algn="ctr"/>
+            <a:endParaRPr/>
           </a:p>
         </p:txBody>
       </p:sp>
@@ -9023,6 +9126,7 @@
           <a:lstStyle/>
           <a:p>
             <a:pPr algn="ctr"/>
+            <a:endParaRPr/>
           </a:p>
         </p:txBody>
       </p:sp>
@@ -9101,6 +9205,7 @@
           <a:lstStyle/>
           <a:p>
             <a:pPr algn="ctr"/>
+            <a:endParaRPr/>
           </a:p>
         </p:txBody>
       </p:sp>
@@ -9179,6 +9284,7 @@
           <a:lstStyle/>
           <a:p>
             <a:pPr algn="ctr"/>
+            <a:endParaRPr/>
           </a:p>
         </p:txBody>
       </p:sp>
@@ -9257,6 +9363,7 @@
           <a:lstStyle/>
           <a:p>
             <a:pPr algn="ctr"/>
+            <a:endParaRPr/>
           </a:p>
         </p:txBody>
       </p:sp>
@@ -9335,6 +9442,7 @@
           <a:lstStyle/>
           <a:p>
             <a:pPr algn="ctr"/>
+            <a:endParaRPr/>
           </a:p>
         </p:txBody>
       </p:sp>
@@ -9413,6 +9521,7 @@
           <a:lstStyle/>
           <a:p>
             <a:pPr algn="ctr"/>
+            <a:endParaRPr/>
           </a:p>
         </p:txBody>
       </p:sp>
@@ -9491,6 +9600,7 @@
           <a:lstStyle/>
           <a:p>
             <a:pPr algn="ctr"/>
+            <a:endParaRPr/>
           </a:p>
         </p:txBody>
       </p:sp>
@@ -9569,6 +9679,7 @@
           <a:lstStyle/>
           <a:p>
             <a:pPr algn="ctr"/>
+            <a:endParaRPr/>
           </a:p>
         </p:txBody>
       </p:sp>
@@ -9647,6 +9758,7 @@
           <a:lstStyle/>
           <a:p>
             <a:pPr algn="ctr"/>
+            <a:endParaRPr/>
           </a:p>
         </p:txBody>
       </p:sp>
@@ -9725,6 +9837,7 @@
           <a:lstStyle/>
           <a:p>
             <a:pPr algn="ctr"/>
+            <a:endParaRPr/>
           </a:p>
         </p:txBody>
       </p:sp>
@@ -9803,6 +9916,7 @@
           <a:lstStyle/>
           <a:p>
             <a:pPr algn="ctr"/>
+            <a:endParaRPr/>
           </a:p>
         </p:txBody>
       </p:sp>
@@ -9881,6 +9995,7 @@
           <a:lstStyle/>
           <a:p>
             <a:pPr algn="ctr"/>
+            <a:endParaRPr/>
           </a:p>
         </p:txBody>
       </p:sp>
@@ -9959,6 +10074,7 @@
           <a:lstStyle/>
           <a:p>
             <a:pPr algn="ctr"/>
+            <a:endParaRPr/>
           </a:p>
         </p:txBody>
       </p:sp>
@@ -10006,7 +10122,7 @@
 </file>
 
 <file path=ppt/slides/slide15.xml><?xml version="1.0" encoding="utf-8"?>
-<p:sld xmlns:a="http://schemas.openxmlformats.org/drawingml/2006/main" xmlns:p="http://schemas.openxmlformats.org/presentationml/2006/main" xmlns:r="http://schemas.openxmlformats.org/officeDocument/2006/relationships">
+<p:sld xmlns:a="http://schemas.openxmlformats.org/drawingml/2006/main" xmlns:r="http://schemas.openxmlformats.org/officeDocument/2006/relationships" xmlns:p="http://schemas.openxmlformats.org/presentationml/2006/main">
   <p:cSld>
     <p:bg>
       <p:bgPr>
@@ -10022,7 +10138,14 @@
         <p:cNvGrpSpPr/>
         <p:nvPr/>
       </p:nvGrpSpPr>
-      <p:grpSpPr/>
+      <p:grpSpPr>
+        <a:xfrm>
+          <a:off x="0" y="0"/>
+          <a:ext cx="0" cy="0"/>
+          <a:chOff x="0" y="0"/>
+          <a:chExt cx="0" cy="0"/>
+        </a:xfrm>
+      </p:grpSpPr>
       <p:sp>
         <p:nvSpPr>
           <p:cNvPr id="2" name="Oval 1"/>
@@ -10063,6 +10186,7 @@
           <a:lstStyle/>
           <a:p>
             <a:pPr algn="ctr"/>
+            <a:endParaRPr/>
           </a:p>
         </p:txBody>
       </p:sp>
@@ -10106,6 +10230,7 @@
           <a:lstStyle/>
           <a:p>
             <a:pPr algn="ctr"/>
+            <a:endParaRPr/>
           </a:p>
         </p:txBody>
       </p:sp>
@@ -10149,6 +10274,7 @@
           <a:lstStyle/>
           <a:p>
             <a:pPr algn="ctr"/>
+            <a:endParaRPr/>
           </a:p>
         </p:txBody>
       </p:sp>
@@ -10192,6 +10318,7 @@
           <a:lstStyle/>
           <a:p>
             <a:pPr algn="ctr"/>
+            <a:endParaRPr/>
           </a:p>
         </p:txBody>
       </p:sp>
@@ -10361,7 +10488,7 @@
 </file>
 
 <file path=ppt/slides/slide2.xml><?xml version="1.0" encoding="utf-8"?>
-<p:sld xmlns:a="http://schemas.openxmlformats.org/drawingml/2006/main" xmlns:p="http://schemas.openxmlformats.org/presentationml/2006/main" xmlns:r="http://schemas.openxmlformats.org/officeDocument/2006/relationships">
+<p:sld xmlns:a="http://schemas.openxmlformats.org/drawingml/2006/main" xmlns:r="http://schemas.openxmlformats.org/officeDocument/2006/relationships" xmlns:p="http://schemas.openxmlformats.org/presentationml/2006/main">
   <p:cSld>
     <p:bg>
       <p:bgPr>
@@ -10377,7 +10504,14 @@
         <p:cNvGrpSpPr/>
         <p:nvPr/>
       </p:nvGrpSpPr>
-      <p:grpSpPr/>
+      <p:grpSpPr>
+        <a:xfrm>
+          <a:off x="0" y="0"/>
+          <a:ext cx="0" cy="0"/>
+          <a:chOff x="0" y="0"/>
+          <a:chExt cx="0" cy="0"/>
+        </a:xfrm>
+      </p:grpSpPr>
       <p:sp>
         <p:nvSpPr>
           <p:cNvPr id="2" name="Rectangle 1"/>
@@ -10418,6 +10552,7 @@
           <a:lstStyle/>
           <a:p>
             <a:pPr algn="ctr"/>
+            <a:endParaRPr/>
           </a:p>
         </p:txBody>
       </p:sp>
@@ -10461,6 +10596,7 @@
           <a:lstStyle/>
           <a:p>
             <a:pPr algn="ctr"/>
+            <a:endParaRPr/>
           </a:p>
         </p:txBody>
       </p:sp>
@@ -10575,6 +10711,7 @@
           <a:lstStyle/>
           <a:p>
             <a:pPr algn="ctr"/>
+            <a:endParaRPr/>
           </a:p>
         </p:txBody>
       </p:sp>
@@ -10772,6 +10909,7 @@
           <a:lstStyle/>
           <a:p>
             <a:pPr algn="ctr"/>
+            <a:endParaRPr/>
           </a:p>
         </p:txBody>
       </p:sp>
@@ -10938,7 +11076,7 @@
 </file>
 
 <file path=ppt/slides/slide3.xml><?xml version="1.0" encoding="utf-8"?>
-<p:sld xmlns:a="http://schemas.openxmlformats.org/drawingml/2006/main" xmlns:p="http://schemas.openxmlformats.org/presentationml/2006/main" xmlns:r="http://schemas.openxmlformats.org/officeDocument/2006/relationships">
+<p:sld xmlns:a="http://schemas.openxmlformats.org/drawingml/2006/main" xmlns:r="http://schemas.openxmlformats.org/officeDocument/2006/relationships" xmlns:p="http://schemas.openxmlformats.org/presentationml/2006/main">
   <p:cSld>
     <p:bg>
       <p:bgPr>
@@ -10954,7 +11092,14 @@
         <p:cNvGrpSpPr/>
         <p:nvPr/>
       </p:nvGrpSpPr>
-      <p:grpSpPr/>
+      <p:grpSpPr>
+        <a:xfrm>
+          <a:off x="0" y="0"/>
+          <a:ext cx="0" cy="0"/>
+          <a:chOff x="0" y="0"/>
+          <a:chExt cx="0" cy="0"/>
+        </a:xfrm>
+      </p:grpSpPr>
       <p:sp>
         <p:nvSpPr>
           <p:cNvPr id="2" name="Rectangle 1"/>
@@ -10995,6 +11140,7 @@
           <a:lstStyle/>
           <a:p>
             <a:pPr algn="ctr"/>
+            <a:endParaRPr/>
           </a:p>
         </p:txBody>
       </p:sp>
@@ -11038,6 +11184,7 @@
           <a:lstStyle/>
           <a:p>
             <a:pPr algn="ctr"/>
+            <a:endParaRPr/>
           </a:p>
         </p:txBody>
       </p:sp>
@@ -11116,6 +11263,7 @@
           <a:lstStyle/>
           <a:p>
             <a:pPr algn="ctr"/>
+            <a:endParaRPr/>
           </a:p>
         </p:txBody>
       </p:sp>
@@ -11165,7 +11313,7 @@
 </file>
 
 <file path=ppt/slides/slide4.xml><?xml version="1.0" encoding="utf-8"?>
-<p:sld xmlns:a="http://schemas.openxmlformats.org/drawingml/2006/main" xmlns:p="http://schemas.openxmlformats.org/presentationml/2006/main" xmlns:r="http://schemas.openxmlformats.org/officeDocument/2006/relationships">
+<p:sld xmlns:a="http://schemas.openxmlformats.org/drawingml/2006/main" xmlns:r="http://schemas.openxmlformats.org/officeDocument/2006/relationships" xmlns:p="http://schemas.openxmlformats.org/presentationml/2006/main">
   <p:cSld>
     <p:bg>
       <p:bgPr>
@@ -11181,7 +11329,14 @@
         <p:cNvGrpSpPr/>
         <p:nvPr/>
       </p:nvGrpSpPr>
-      <p:grpSpPr/>
+      <p:grpSpPr>
+        <a:xfrm>
+          <a:off x="0" y="0"/>
+          <a:ext cx="0" cy="0"/>
+          <a:chOff x="0" y="0"/>
+          <a:chExt cx="0" cy="0"/>
+        </a:xfrm>
+      </p:grpSpPr>
       <p:sp>
         <p:nvSpPr>
           <p:cNvPr id="2" name="Rectangle 1"/>
@@ -11222,6 +11377,7 @@
           <a:lstStyle/>
           <a:p>
             <a:pPr algn="ctr"/>
+            <a:endParaRPr/>
           </a:p>
         </p:txBody>
       </p:sp>
@@ -11265,6 +11421,7 @@
           <a:lstStyle/>
           <a:p>
             <a:pPr algn="ctr"/>
+            <a:endParaRPr/>
           </a:p>
         </p:txBody>
       </p:sp>
@@ -11343,6 +11500,7 @@
           <a:lstStyle/>
           <a:p>
             <a:pPr algn="ctr"/>
+            <a:endParaRPr/>
           </a:p>
         </p:txBody>
       </p:sp>
@@ -11386,6 +11544,7 @@
           <a:lstStyle/>
           <a:p>
             <a:pPr algn="ctr"/>
+            <a:endParaRPr/>
           </a:p>
         </p:txBody>
       </p:sp>
@@ -11535,6 +11694,7 @@
           <a:lstStyle/>
           <a:p>
             <a:pPr algn="ctr"/>
+            <a:endParaRPr/>
           </a:p>
         </p:txBody>
       </p:sp>
@@ -11578,6 +11738,7 @@
           <a:lstStyle/>
           <a:p>
             <a:pPr algn="ctr"/>
+            <a:endParaRPr/>
           </a:p>
         </p:txBody>
       </p:sp>
@@ -11727,6 +11888,7 @@
           <a:lstStyle/>
           <a:p>
             <a:pPr algn="ctr"/>
+            <a:endParaRPr/>
           </a:p>
         </p:txBody>
       </p:sp>
@@ -11770,6 +11932,7 @@
           <a:lstStyle/>
           <a:p>
             <a:pPr algn="ctr"/>
+            <a:endParaRPr/>
           </a:p>
         </p:txBody>
       </p:sp>
@@ -11919,6 +12082,7 @@
           <a:lstStyle/>
           <a:p>
             <a:pPr algn="ctr"/>
+            <a:endParaRPr/>
           </a:p>
         </p:txBody>
       </p:sp>
@@ -11962,6 +12126,7 @@
           <a:lstStyle/>
           <a:p>
             <a:pPr algn="ctr"/>
+            <a:endParaRPr/>
           </a:p>
         </p:txBody>
       </p:sp>
@@ -12080,7 +12245,7 @@
 </file>
 
 <file path=ppt/slides/slide5.xml><?xml version="1.0" encoding="utf-8"?>
-<p:sld xmlns:a="http://schemas.openxmlformats.org/drawingml/2006/main" xmlns:p="http://schemas.openxmlformats.org/presentationml/2006/main" xmlns:r="http://schemas.openxmlformats.org/officeDocument/2006/relationships">
+<p:sld xmlns:a="http://schemas.openxmlformats.org/drawingml/2006/main" xmlns:r="http://schemas.openxmlformats.org/officeDocument/2006/relationships" xmlns:p="http://schemas.openxmlformats.org/presentationml/2006/main">
   <p:cSld>
     <p:bg>
       <p:bgPr>
@@ -12096,7 +12261,14 @@
         <p:cNvGrpSpPr/>
         <p:nvPr/>
       </p:nvGrpSpPr>
-      <p:grpSpPr/>
+      <p:grpSpPr>
+        <a:xfrm>
+          <a:off x="0" y="0"/>
+          <a:ext cx="0" cy="0"/>
+          <a:chOff x="0" y="0"/>
+          <a:chExt cx="0" cy="0"/>
+        </a:xfrm>
+      </p:grpSpPr>
       <p:sp>
         <p:nvSpPr>
           <p:cNvPr id="2" name="Rectangle 1"/>
@@ -12137,6 +12309,7 @@
           <a:lstStyle/>
           <a:p>
             <a:pPr algn="ctr"/>
+            <a:endParaRPr/>
           </a:p>
         </p:txBody>
       </p:sp>
@@ -12180,6 +12353,7 @@
           <a:lstStyle/>
           <a:p>
             <a:pPr algn="ctr"/>
+            <a:endParaRPr/>
           </a:p>
         </p:txBody>
       </p:sp>
@@ -12258,6 +12432,7 @@
           <a:lstStyle/>
           <a:p>
             <a:pPr algn="ctr"/>
+            <a:endParaRPr/>
           </a:p>
         </p:txBody>
       </p:sp>
@@ -12301,6 +12476,7 @@
           <a:lstStyle/>
           <a:p>
             <a:pPr algn="ctr"/>
+            <a:endParaRPr/>
           </a:p>
         </p:txBody>
       </p:sp>
@@ -12450,6 +12626,7 @@
           <a:lstStyle/>
           <a:p>
             <a:pPr algn="ctr"/>
+            <a:endParaRPr/>
           </a:p>
         </p:txBody>
       </p:sp>
@@ -12493,6 +12670,7 @@
           <a:lstStyle/>
           <a:p>
             <a:pPr algn="ctr"/>
+            <a:endParaRPr/>
           </a:p>
         </p:txBody>
       </p:sp>
@@ -12643,6 +12821,7 @@
           <a:lstStyle/>
           <a:p>
             <a:pPr algn="ctr"/>
+            <a:endParaRPr/>
           </a:p>
         </p:txBody>
       </p:sp>
@@ -12686,6 +12865,7 @@
           <a:lstStyle/>
           <a:p>
             <a:pPr algn="ctr"/>
+            <a:endParaRPr/>
           </a:p>
         </p:txBody>
       </p:sp>
@@ -12804,7 +12984,7 @@
 </file>
 
 <file path=ppt/slides/slide6.xml><?xml version="1.0" encoding="utf-8"?>
-<p:sld xmlns:a="http://schemas.openxmlformats.org/drawingml/2006/main" xmlns:p="http://schemas.openxmlformats.org/presentationml/2006/main" xmlns:r="http://schemas.openxmlformats.org/officeDocument/2006/relationships">
+<p:sld xmlns:a="http://schemas.openxmlformats.org/drawingml/2006/main" xmlns:r="http://schemas.openxmlformats.org/officeDocument/2006/relationships" xmlns:p="http://schemas.openxmlformats.org/presentationml/2006/main">
   <p:cSld>
     <p:bg>
       <p:bgPr>
@@ -12820,7 +13000,14 @@
         <p:cNvGrpSpPr/>
         <p:nvPr/>
       </p:nvGrpSpPr>
-      <p:grpSpPr/>
+      <p:grpSpPr>
+        <a:xfrm>
+          <a:off x="0" y="0"/>
+          <a:ext cx="0" cy="0"/>
+          <a:chOff x="0" y="0"/>
+          <a:chExt cx="0" cy="0"/>
+        </a:xfrm>
+      </p:grpSpPr>
       <p:sp>
         <p:nvSpPr>
           <p:cNvPr id="2" name="Rectangle 1"/>
@@ -12861,6 +13048,7 @@
           <a:lstStyle/>
           <a:p>
             <a:pPr algn="ctr"/>
+            <a:endParaRPr/>
           </a:p>
         </p:txBody>
       </p:sp>
@@ -12904,6 +13092,7 @@
           <a:lstStyle/>
           <a:p>
             <a:pPr algn="ctr"/>
+            <a:endParaRPr/>
           </a:p>
         </p:txBody>
       </p:sp>
@@ -12982,6 +13171,7 @@
           <a:lstStyle/>
           <a:p>
             <a:pPr algn="ctr"/>
+            <a:endParaRPr/>
           </a:p>
         </p:txBody>
       </p:sp>
@@ -13066,7 +13256,7 @@
 </file>
 
 <file path=ppt/slides/slide7.xml><?xml version="1.0" encoding="utf-8"?>
-<p:sld xmlns:a="http://schemas.openxmlformats.org/drawingml/2006/main" xmlns:p="http://schemas.openxmlformats.org/presentationml/2006/main" xmlns:r="http://schemas.openxmlformats.org/officeDocument/2006/relationships">
+<p:sld xmlns:a="http://schemas.openxmlformats.org/drawingml/2006/main" xmlns:r="http://schemas.openxmlformats.org/officeDocument/2006/relationships" xmlns:p="http://schemas.openxmlformats.org/presentationml/2006/main">
   <p:cSld>
     <p:bg>
       <p:bgPr>
@@ -13082,7 +13272,14 @@
         <p:cNvGrpSpPr/>
         <p:nvPr/>
       </p:nvGrpSpPr>
-      <p:grpSpPr/>
+      <p:grpSpPr>
+        <a:xfrm>
+          <a:off x="0" y="0"/>
+          <a:ext cx="0" cy="0"/>
+          <a:chOff x="0" y="0"/>
+          <a:chExt cx="0" cy="0"/>
+        </a:xfrm>
+      </p:grpSpPr>
       <p:sp>
         <p:nvSpPr>
           <p:cNvPr id="2" name="Rectangle 1"/>
@@ -13123,6 +13320,7 @@
           <a:lstStyle/>
           <a:p>
             <a:pPr algn="ctr"/>
+            <a:endParaRPr/>
           </a:p>
         </p:txBody>
       </p:sp>
@@ -13166,6 +13364,7 @@
           <a:lstStyle/>
           <a:p>
             <a:pPr algn="ctr"/>
+            <a:endParaRPr/>
           </a:p>
         </p:txBody>
       </p:sp>
@@ -13244,6 +13443,7 @@
           <a:lstStyle/>
           <a:p>
             <a:pPr algn="ctr"/>
+            <a:endParaRPr/>
           </a:p>
         </p:txBody>
       </p:sp>
@@ -13323,6 +13523,7 @@
           <a:lstStyle/>
           <a:p>
             <a:pPr algn="ctr"/>
+            <a:endParaRPr/>
           </a:p>
         </p:txBody>
       </p:sp>
@@ -13469,6 +13670,7 @@
           <a:lstStyle/>
           <a:p>
             <a:pPr algn="ctr"/>
+            <a:endParaRPr/>
           </a:p>
         </p:txBody>
       </p:sp>
@@ -13548,6 +13750,7 @@
           <a:lstStyle/>
           <a:p>
             <a:pPr algn="ctr"/>
+            <a:endParaRPr/>
           </a:p>
         </p:txBody>
       </p:sp>
@@ -13694,6 +13897,7 @@
           <a:lstStyle/>
           <a:p>
             <a:pPr algn="ctr"/>
+            <a:endParaRPr/>
           </a:p>
         </p:txBody>
       </p:sp>
@@ -13773,6 +13977,7 @@
           <a:lstStyle/>
           <a:p>
             <a:pPr algn="ctr"/>
+            <a:endParaRPr/>
           </a:p>
         </p:txBody>
       </p:sp>
@@ -13919,6 +14124,7 @@
           <a:lstStyle/>
           <a:p>
             <a:pPr algn="ctr"/>
+            <a:endParaRPr/>
           </a:p>
         </p:txBody>
       </p:sp>
@@ -13998,6 +14204,7 @@
           <a:lstStyle/>
           <a:p>
             <a:pPr algn="ctr"/>
+            <a:endParaRPr/>
           </a:p>
         </p:txBody>
       </p:sp>
@@ -14113,7 +14320,7 @@
 </file>
 
 <file path=ppt/slides/slide8.xml><?xml version="1.0" encoding="utf-8"?>
-<p:sld xmlns:a="http://schemas.openxmlformats.org/drawingml/2006/main" xmlns:p="http://schemas.openxmlformats.org/presentationml/2006/main" xmlns:r="http://schemas.openxmlformats.org/officeDocument/2006/relationships">
+<p:sld xmlns:a="http://schemas.openxmlformats.org/drawingml/2006/main" xmlns:r="http://schemas.openxmlformats.org/officeDocument/2006/relationships" xmlns:p="http://schemas.openxmlformats.org/presentationml/2006/main">
   <p:cSld>
     <p:bg>
       <p:bgPr>
@@ -14129,7 +14336,14 @@
         <p:cNvGrpSpPr/>
         <p:nvPr/>
       </p:nvGrpSpPr>
-      <p:grpSpPr/>
+      <p:grpSpPr>
+        <a:xfrm>
+          <a:off x="0" y="0"/>
+          <a:ext cx="0" cy="0"/>
+          <a:chOff x="0" y="0"/>
+          <a:chExt cx="0" cy="0"/>
+        </a:xfrm>
+      </p:grpSpPr>
       <p:sp>
         <p:nvSpPr>
           <p:cNvPr id="2" name="Rectangle 1"/>
@@ -14170,6 +14384,7 @@
           <a:lstStyle/>
           <a:p>
             <a:pPr algn="ctr"/>
+            <a:endParaRPr/>
           </a:p>
         </p:txBody>
       </p:sp>
@@ -14213,6 +14428,7 @@
           <a:lstStyle/>
           <a:p>
             <a:pPr algn="ctr"/>
+            <a:endParaRPr/>
           </a:p>
         </p:txBody>
       </p:sp>
@@ -14291,6 +14507,7 @@
           <a:lstStyle/>
           <a:p>
             <a:pPr algn="ctr"/>
+            <a:endParaRPr/>
           </a:p>
         </p:txBody>
       </p:sp>
@@ -14405,6 +14622,7 @@
           <a:lstStyle/>
           <a:p>
             <a:pPr algn="ctr"/>
+            <a:endParaRPr/>
           </a:p>
         </p:txBody>
       </p:sp>
@@ -14521,6 +14739,7 @@
           <a:lstStyle/>
           <a:p>
             <a:pPr algn="ctr"/>
+            <a:endParaRPr/>
           </a:p>
         </p:txBody>
       </p:sp>
@@ -14671,7 +14890,7 @@
 </file>
 
 <file path=ppt/slides/slide9.xml><?xml version="1.0" encoding="utf-8"?>
-<p:sld xmlns:a="http://schemas.openxmlformats.org/drawingml/2006/main" xmlns:p="http://schemas.openxmlformats.org/presentationml/2006/main" xmlns:r="http://schemas.openxmlformats.org/officeDocument/2006/relationships">
+<p:sld xmlns:a="http://schemas.openxmlformats.org/drawingml/2006/main" xmlns:r="http://schemas.openxmlformats.org/officeDocument/2006/relationships" xmlns:p="http://schemas.openxmlformats.org/presentationml/2006/main">
   <p:cSld>
     <p:bg>
       <p:bgPr>
@@ -14687,7 +14906,14 @@
         <p:cNvGrpSpPr/>
         <p:nvPr/>
       </p:nvGrpSpPr>
-      <p:grpSpPr/>
+      <p:grpSpPr>
+        <a:xfrm>
+          <a:off x="0" y="0"/>
+          <a:ext cx="0" cy="0"/>
+          <a:chOff x="0" y="0"/>
+          <a:chExt cx="0" cy="0"/>
+        </a:xfrm>
+      </p:grpSpPr>
       <p:sp>
         <p:nvSpPr>
           <p:cNvPr id="2" name="Rectangle 1"/>
@@ -14728,6 +14954,7 @@
           <a:lstStyle/>
           <a:p>
             <a:pPr algn="ctr"/>
+            <a:endParaRPr/>
           </a:p>
         </p:txBody>
       </p:sp>
@@ -14771,6 +14998,7 @@
           <a:lstStyle/>
           <a:p>
             <a:pPr algn="ctr"/>
+            <a:endParaRPr/>
           </a:p>
         </p:txBody>
       </p:sp>
@@ -14849,6 +15077,7 @@
           <a:lstStyle/>
           <a:p>
             <a:pPr algn="ctr"/>
+            <a:endParaRPr/>
           </a:p>
         </p:txBody>
       </p:sp>
@@ -14965,6 +15194,7 @@
           <a:lstStyle/>
           <a:p>
             <a:pPr algn="ctr"/>
+            <a:endParaRPr/>
           </a:p>
         </p:txBody>
       </p:sp>
@@ -15079,6 +15309,7 @@
           <a:lstStyle/>
           <a:p>
             <a:pPr algn="ctr"/>
+            <a:endParaRPr/>
           </a:p>
         </p:txBody>
       </p:sp>

</xml_diff>